<commit_message>
Update readme and validation app
</commit_message>
<xml_diff>
--- a/manual/flowchart_v2.pptx
+++ b/manual/flowchart_v2.pptx
@@ -2881,7 +2881,7 @@
           <a:p>
             <a:fld id="{5C0B834B-9BC9-426A-9A25-1E46587FB363}" type="datetimeFigureOut">
               <a:rPr lang="en-CA" smtClean="0"/>
-              <a:t>2026-05-29</a:t>
+              <a:t>2026-06-11</a:t>
             </a:fld>
             <a:endParaRPr lang="en-CA"/>
           </a:p>
@@ -3051,7 +3051,7 @@
           <a:p>
             <a:fld id="{5C0B834B-9BC9-426A-9A25-1E46587FB363}" type="datetimeFigureOut">
               <a:rPr lang="en-CA" smtClean="0"/>
-              <a:t>2026-05-29</a:t>
+              <a:t>2026-06-11</a:t>
             </a:fld>
             <a:endParaRPr lang="en-CA"/>
           </a:p>
@@ -3231,7 +3231,7 @@
           <a:p>
             <a:fld id="{5C0B834B-9BC9-426A-9A25-1E46587FB363}" type="datetimeFigureOut">
               <a:rPr lang="en-CA" smtClean="0"/>
-              <a:t>2026-05-29</a:t>
+              <a:t>2026-06-11</a:t>
             </a:fld>
             <a:endParaRPr lang="en-CA"/>
           </a:p>
@@ -3401,7 +3401,7 @@
           <a:p>
             <a:fld id="{5C0B834B-9BC9-426A-9A25-1E46587FB363}" type="datetimeFigureOut">
               <a:rPr lang="en-CA" smtClean="0"/>
-              <a:t>2026-05-29</a:t>
+              <a:t>2026-06-11</a:t>
             </a:fld>
             <a:endParaRPr lang="en-CA"/>
           </a:p>
@@ -3645,7 +3645,7 @@
           <a:p>
             <a:fld id="{5C0B834B-9BC9-426A-9A25-1E46587FB363}" type="datetimeFigureOut">
               <a:rPr lang="en-CA" smtClean="0"/>
-              <a:t>2026-05-29</a:t>
+              <a:t>2026-06-11</a:t>
             </a:fld>
             <a:endParaRPr lang="en-CA"/>
           </a:p>
@@ -3877,7 +3877,7 @@
           <a:p>
             <a:fld id="{5C0B834B-9BC9-426A-9A25-1E46587FB363}" type="datetimeFigureOut">
               <a:rPr lang="en-CA" smtClean="0"/>
-              <a:t>2026-05-29</a:t>
+              <a:t>2026-06-11</a:t>
             </a:fld>
             <a:endParaRPr lang="en-CA"/>
           </a:p>
@@ -4244,7 +4244,7 @@
           <a:p>
             <a:fld id="{5C0B834B-9BC9-426A-9A25-1E46587FB363}" type="datetimeFigureOut">
               <a:rPr lang="en-CA" smtClean="0"/>
-              <a:t>2026-05-29</a:t>
+              <a:t>2026-06-11</a:t>
             </a:fld>
             <a:endParaRPr lang="en-CA"/>
           </a:p>
@@ -4362,7 +4362,7 @@
           <a:p>
             <a:fld id="{5C0B834B-9BC9-426A-9A25-1E46587FB363}" type="datetimeFigureOut">
               <a:rPr lang="en-CA" smtClean="0"/>
-              <a:t>2026-05-29</a:t>
+              <a:t>2026-06-11</a:t>
             </a:fld>
             <a:endParaRPr lang="en-CA"/>
           </a:p>
@@ -4457,7 +4457,7 @@
           <a:p>
             <a:fld id="{5C0B834B-9BC9-426A-9A25-1E46587FB363}" type="datetimeFigureOut">
               <a:rPr lang="en-CA" smtClean="0"/>
-              <a:t>2026-05-29</a:t>
+              <a:t>2026-06-11</a:t>
             </a:fld>
             <a:endParaRPr lang="en-CA"/>
           </a:p>
@@ -4734,7 +4734,7 @@
           <a:p>
             <a:fld id="{5C0B834B-9BC9-426A-9A25-1E46587FB363}" type="datetimeFigureOut">
               <a:rPr lang="en-CA" smtClean="0"/>
-              <a:t>2026-05-29</a:t>
+              <a:t>2026-06-11</a:t>
             </a:fld>
             <a:endParaRPr lang="en-CA"/>
           </a:p>
@@ -4991,7 +4991,7 @@
           <a:p>
             <a:fld id="{5C0B834B-9BC9-426A-9A25-1E46587FB363}" type="datetimeFigureOut">
               <a:rPr lang="en-CA" smtClean="0"/>
-              <a:t>2026-05-29</a:t>
+              <a:t>2026-06-11</a:t>
             </a:fld>
             <a:endParaRPr lang="en-CA"/>
           </a:p>
@@ -5204,7 +5204,7 @@
           <a:p>
             <a:fld id="{5C0B834B-9BC9-426A-9A25-1E46587FB363}" type="datetimeFigureOut">
               <a:rPr lang="en-CA" smtClean="0"/>
-              <a:t>2026-05-29</a:t>
+              <a:t>2026-06-11</a:t>
             </a:fld>
             <a:endParaRPr lang="en-CA"/>
           </a:p>
@@ -8121,7 +8121,7 @@
                 </a:solidFill>
                 <a:cs typeface="Arial"/>
               </a:rPr>
-              <a:t>7. Optional: Temporal Mapping</a:t>
+              <a:t>7. Optional: Temporal mapping</a:t>
             </a:r>
             <a:endParaRPr lang="en-CA" sz="1400" dirty="0">
               <a:solidFill>

</xml_diff>